<commit_message>
replaced the QR code in poster to point to public version of repo
</commit_message>
<xml_diff>
--- a/final_presentation/final_poster.pptx
+++ b/final_presentation/final_poster.pptx
@@ -197,7 +197,7 @@
           <a:p>
             <a:fld id="{9963C06F-E095-F145-85C3-E8ED00EA93A6}" type="datetimeFigureOut">
               <a:rPr lang="en-US" smtClean="0"/>
-              <a:t>4/16/26</a:t>
+              <a:t>4/23/26</a:t>
             </a:fld>
             <a:endParaRPr lang="en-US"/>
           </a:p>
@@ -847,7 +847,7 @@
           <a:p>
             <a:fld id="{3F135061-2F74-46D4-9F8F-C77EF304855D}" type="datetimeFigureOut">
               <a:rPr lang="en-US" smtClean="0"/>
-              <a:t>4/16/26</a:t>
+              <a:t>4/23/26</a:t>
             </a:fld>
             <a:endParaRPr lang="en-US"/>
           </a:p>
@@ -1017,7 +1017,7 @@
           <a:p>
             <a:fld id="{3F135061-2F74-46D4-9F8F-C77EF304855D}" type="datetimeFigureOut">
               <a:rPr lang="en-US" smtClean="0"/>
-              <a:t>4/16/26</a:t>
+              <a:t>4/23/26</a:t>
             </a:fld>
             <a:endParaRPr lang="en-US"/>
           </a:p>
@@ -1197,7 +1197,7 @@
           <a:p>
             <a:fld id="{3F135061-2F74-46D4-9F8F-C77EF304855D}" type="datetimeFigureOut">
               <a:rPr lang="en-US" smtClean="0"/>
-              <a:t>4/16/26</a:t>
+              <a:t>4/23/26</a:t>
             </a:fld>
             <a:endParaRPr lang="en-US"/>
           </a:p>
@@ -1367,7 +1367,7 @@
           <a:p>
             <a:fld id="{3F135061-2F74-46D4-9F8F-C77EF304855D}" type="datetimeFigureOut">
               <a:rPr lang="en-US" smtClean="0"/>
-              <a:t>4/16/26</a:t>
+              <a:t>4/23/26</a:t>
             </a:fld>
             <a:endParaRPr lang="en-US"/>
           </a:p>
@@ -1611,7 +1611,7 @@
           <a:p>
             <a:fld id="{3F135061-2F74-46D4-9F8F-C77EF304855D}" type="datetimeFigureOut">
               <a:rPr lang="en-US" smtClean="0"/>
-              <a:t>4/16/26</a:t>
+              <a:t>4/23/26</a:t>
             </a:fld>
             <a:endParaRPr lang="en-US"/>
           </a:p>
@@ -1843,7 +1843,7 @@
           <a:p>
             <a:fld id="{3F135061-2F74-46D4-9F8F-C77EF304855D}" type="datetimeFigureOut">
               <a:rPr lang="en-US" smtClean="0"/>
-              <a:t>4/16/26</a:t>
+              <a:t>4/23/26</a:t>
             </a:fld>
             <a:endParaRPr lang="en-US"/>
           </a:p>
@@ -2210,7 +2210,7 @@
           <a:p>
             <a:fld id="{3F135061-2F74-46D4-9F8F-C77EF304855D}" type="datetimeFigureOut">
               <a:rPr lang="en-US" smtClean="0"/>
-              <a:t>4/16/26</a:t>
+              <a:t>4/23/26</a:t>
             </a:fld>
             <a:endParaRPr lang="en-US"/>
           </a:p>
@@ -2328,7 +2328,7 @@
           <a:p>
             <a:fld id="{3F135061-2F74-46D4-9F8F-C77EF304855D}" type="datetimeFigureOut">
               <a:rPr lang="en-US" smtClean="0"/>
-              <a:t>4/16/26</a:t>
+              <a:t>4/23/26</a:t>
             </a:fld>
             <a:endParaRPr lang="en-US"/>
           </a:p>
@@ -2423,7 +2423,7 @@
           <a:p>
             <a:fld id="{3F135061-2F74-46D4-9F8F-C77EF304855D}" type="datetimeFigureOut">
               <a:rPr lang="en-US" smtClean="0"/>
-              <a:t>4/16/26</a:t>
+              <a:t>4/23/26</a:t>
             </a:fld>
             <a:endParaRPr lang="en-US"/>
           </a:p>
@@ -2700,7 +2700,7 @@
           <a:p>
             <a:fld id="{3F135061-2F74-46D4-9F8F-C77EF304855D}" type="datetimeFigureOut">
               <a:rPr lang="en-US" smtClean="0"/>
-              <a:t>4/16/26</a:t>
+              <a:t>4/23/26</a:t>
             </a:fld>
             <a:endParaRPr lang="en-US"/>
           </a:p>
@@ -2957,7 +2957,7 @@
           <a:p>
             <a:fld id="{3F135061-2F74-46D4-9F8F-C77EF304855D}" type="datetimeFigureOut">
               <a:rPr lang="en-US" smtClean="0"/>
-              <a:t>4/16/26</a:t>
+              <a:t>4/23/26</a:t>
             </a:fld>
             <a:endParaRPr lang="en-US"/>
           </a:p>
@@ -3170,7 +3170,7 @@
           <a:p>
             <a:fld id="{3F135061-2F74-46D4-9F8F-C77EF304855D}" type="datetimeFigureOut">
               <a:rPr lang="en-US" smtClean="0"/>
-              <a:t>4/16/26</a:t>
+              <a:t>4/23/26</a:t>
             </a:fld>
             <a:endParaRPr lang="en-US"/>
           </a:p>
@@ -4025,7 +4025,7 @@
         </p:nvSpPr>
         <p:spPr>
           <a:xfrm>
-            <a:off x="19048206" y="30779034"/>
+            <a:off x="18775302" y="30663943"/>
             <a:ext cx="4770892" cy="1938992"/>
           </a:xfrm>
           <a:prstGeom prst="rect">
@@ -4057,7 +4057,7 @@
               <a:defRPr/>
             </a:pPr>
             <a:r>
-              <a:rPr kumimoji="0" lang="en-US" sz="4000" b="0" i="0" u="none" strike="noStrike" kern="1200" cap="none" spc="0" normalizeH="0" baseline="0" noProof="0" dirty="0">
+              <a:rPr kumimoji="0" lang="en-US" sz="4000" b="1" i="0" u="none" strike="noStrike" kern="1200" cap="none" spc="0" normalizeH="0" baseline="0" noProof="0" dirty="0">
                 <a:ln>
                   <a:noFill/>
                 </a:ln>
@@ -4077,7 +4077,7 @@
               <a:t>Scan to </a:t>
             </a:r>
             <a:br>
-              <a:rPr kumimoji="0" lang="en-US" sz="4000" b="0" i="0" u="none" strike="noStrike" kern="1200" cap="none" spc="0" normalizeH="0" baseline="0" noProof="0" dirty="0">
+              <a:rPr kumimoji="0" lang="en-US" sz="4000" b="1" i="0" u="none" strike="noStrike" kern="1200" cap="none" spc="0" normalizeH="0" baseline="0" noProof="0" dirty="0">
                 <a:ln>
                   <a:noFill/>
                 </a:ln>
@@ -4096,26 +4096,6 @@
               </a:rPr>
             </a:br>
             <a:r>
-              <a:rPr kumimoji="0" lang="en-US" sz="4000" b="0" i="0" u="none" strike="noStrike" kern="1200" cap="none" spc="0" normalizeH="0" baseline="0" noProof="0" dirty="0">
-                <a:ln>
-                  <a:noFill/>
-                </a:ln>
-                <a:solidFill>
-                  <a:prstClr val="black">
-                    <a:lumMod val="75000"/>
-                    <a:lumOff val="25000"/>
-                  </a:prstClr>
-                </a:solidFill>
-                <a:effectLst/>
-                <a:uLnTx/>
-                <a:uFillTx/>
-                <a:latin typeface="Arial" panose="020B0604020202020204" pitchFamily="34" charset="0"/>
-                <a:ea typeface="+mn-ea"/>
-                <a:cs typeface="Arial" panose="020B0604020202020204" pitchFamily="34" charset="0"/>
-              </a:rPr>
-              <a:t>view the</a:t>
-            </a:r>
-            <a:r>
               <a:rPr kumimoji="0" lang="en-US" sz="4000" b="1" i="0" u="none" strike="noStrike" kern="1200" cap="none" spc="0" normalizeH="0" baseline="0" noProof="0" dirty="0">
                 <a:ln>
                   <a:noFill/>
@@ -4133,27 +4113,7 @@
                 <a:ea typeface="+mn-ea"/>
                 <a:cs typeface="Arial" panose="020B0604020202020204" pitchFamily="34" charset="0"/>
               </a:rPr>
-              <a:t> </a:t>
-            </a:r>
-            <a:r>
-              <a:rPr kumimoji="0" lang="en-US" sz="4000" b="0" i="0" u="none" strike="noStrike" kern="1200" cap="none" spc="0" normalizeH="0" baseline="0" noProof="0" dirty="0">
-                <a:ln>
-                  <a:noFill/>
-                </a:ln>
-                <a:solidFill>
-                  <a:prstClr val="black">
-                    <a:lumMod val="75000"/>
-                    <a:lumOff val="25000"/>
-                  </a:prstClr>
-                </a:solidFill>
-                <a:effectLst/>
-                <a:uLnTx/>
-                <a:uFillTx/>
-                <a:latin typeface="Arial" panose="020B0604020202020204" pitchFamily="34" charset="0"/>
-                <a:ea typeface="+mn-ea"/>
-                <a:cs typeface="Arial" panose="020B0604020202020204" pitchFamily="34" charset="0"/>
-              </a:rPr>
-              <a:t>project on GitHub</a:t>
+              <a:t>view the project on GitHub</a:t>
             </a:r>
           </a:p>
         </p:txBody>
@@ -4174,7 +4134,7 @@
         </p:nvCxnSpPr>
         <p:spPr>
           <a:xfrm flipH="1">
-            <a:off x="17365375" y="31933196"/>
+            <a:off x="17284222" y="31633439"/>
             <a:ext cx="1297464" cy="0"/>
           </a:xfrm>
           <a:prstGeom prst="straightConnector1">
@@ -4492,36 +4452,6 @@
       </p:pic>
       <p:pic>
         <p:nvPicPr>
-          <p:cNvPr id="11" name="Picture 10">
-            <a:extLst>
-              <a:ext uri="{FF2B5EF4-FFF2-40B4-BE49-F238E27FC236}">
-                <a16:creationId xmlns:a16="http://schemas.microsoft.com/office/drawing/2014/main" id="{0204CDE2-1752-7B02-15B0-3D1859AF4475}"/>
-              </a:ext>
-            </a:extLst>
-          </p:cNvPr>
-          <p:cNvPicPr>
-            <a:picLocks noChangeAspect="1"/>
-          </p:cNvPicPr>
-          <p:nvPr/>
-        </p:nvPicPr>
-        <p:blipFill>
-          <a:blip r:embed="rId8"/>
-          <a:stretch>
-            <a:fillRect/>
-          </a:stretch>
-        </p:blipFill>
-        <p:spPr>
-          <a:xfrm>
-            <a:off x="14197620" y="30184072"/>
-            <a:ext cx="2767264" cy="2729700"/>
-          </a:xfrm>
-          <a:prstGeom prst="rect">
-            <a:avLst/>
-          </a:prstGeom>
-        </p:spPr>
-      </p:pic>
-      <p:pic>
-        <p:nvPicPr>
           <p:cNvPr id="18" name="Picture 17">
             <a:extLst>
               <a:ext uri="{FF2B5EF4-FFF2-40B4-BE49-F238E27FC236}">
@@ -4535,7 +4465,7 @@
           <p:nvPr/>
         </p:nvPicPr>
         <p:blipFill>
-          <a:blip r:embed="rId9"/>
+          <a:blip r:embed="rId8"/>
           <a:srcRect l="6701" t="7162" r="3152" b="25229"/>
           <a:stretch>
             <a:fillRect/>
@@ -4574,7 +4504,7 @@
           <p:nvPr/>
         </p:nvPicPr>
         <p:blipFill>
-          <a:blip r:embed="rId10"/>
+          <a:blip r:embed="rId9"/>
           <a:srcRect l="278" t="10122" r="19965" b="1021"/>
           <a:stretch>
             <a:fillRect/>
@@ -4790,7 +4720,7 @@
           <p:nvPr/>
         </p:nvPicPr>
         <p:blipFill>
-          <a:blip r:embed="rId11"/>
+          <a:blip r:embed="rId10"/>
           <a:srcRect t="17469" b="9274"/>
           <a:stretch>
             <a:fillRect/>
@@ -5046,7 +4976,7 @@
           <p:nvPr/>
         </p:nvPicPr>
         <p:blipFill>
-          <a:blip r:embed="rId12"/>
+          <a:blip r:embed="rId11"/>
           <a:srcRect/>
           <a:stretch/>
         </p:blipFill>
@@ -5345,7 +5275,7 @@
           <p:nvPr/>
         </p:nvPicPr>
         <p:blipFill>
-          <a:blip r:embed="rId10"/>
+          <a:blip r:embed="rId9"/>
           <a:srcRect l="80781" t="15836" r="-279" b="8506"/>
           <a:stretch>
             <a:fillRect/>
@@ -5815,7 +5745,7 @@
           <p:nvPr/>
         </p:nvPicPr>
         <p:blipFill>
-          <a:blip r:embed="rId11"/>
+          <a:blip r:embed="rId10"/>
           <a:srcRect l="62090" t="89222" b="4507"/>
           <a:stretch>
             <a:fillRect/>
@@ -5846,7 +5776,7 @@
           <p:nvPr/>
         </p:nvPicPr>
         <p:blipFill>
-          <a:blip r:embed="rId11"/>
+          <a:blip r:embed="rId10"/>
           <a:srcRect t="91662" r="40514" b="3226"/>
           <a:stretch>
             <a:fillRect/>
@@ -6071,6 +6001,36 @@
           </a:p>
         </p:txBody>
       </p:sp>
+      <p:pic>
+        <p:nvPicPr>
+          <p:cNvPr id="4" name="Picture 3">
+            <a:extLst>
+              <a:ext uri="{FF2B5EF4-FFF2-40B4-BE49-F238E27FC236}">
+                <a16:creationId xmlns:a16="http://schemas.microsoft.com/office/drawing/2014/main" id="{1E8F48DC-2FA2-5320-320E-BEE7424A1BD0}"/>
+              </a:ext>
+            </a:extLst>
+          </p:cNvPr>
+          <p:cNvPicPr>
+            <a:picLocks noChangeAspect="1"/>
+          </p:cNvPicPr>
+          <p:nvPr/>
+        </p:nvPicPr>
+        <p:blipFill>
+          <a:blip r:embed="rId12"/>
+          <a:stretch>
+            <a:fillRect/>
+          </a:stretch>
+        </p:blipFill>
+        <p:spPr>
+          <a:xfrm>
+            <a:off x="14551382" y="30358469"/>
+            <a:ext cx="2549940" cy="2549940"/>
+          </a:xfrm>
+          <a:prstGeom prst="rect">
+            <a:avLst/>
+          </a:prstGeom>
+        </p:spPr>
+      </p:pic>
     </p:spTree>
     <p:extLst>
       <p:ext uri="{BB962C8B-B14F-4D97-AF65-F5344CB8AC3E}">

</xml_diff>